<commit_message>
Deploy preview for PR 129 🛫
</commit_message>
<xml_diff>
--- a/pr-preview/pr-129/assets/downloads/Presentation_Slides_Template.pptx
+++ b/pr-preview/pr-129/assets/downloads/Presentation_Slides_Template.pptx
@@ -130,7 +130,7 @@
 <file path=ppt/revisionInfo.xml><?xml version="1.0" encoding="utf-8"?>
 <p1510:revInfo xmlns:a="http://schemas.openxmlformats.org/drawingml/2006/main" xmlns:r="http://schemas.openxmlformats.org/officeDocument/2006/relationships" xmlns:p1510="http://schemas.microsoft.com/office/powerpoint/2015/10/main">
   <p1510:revLst>
-    <p1510:client id="{9203E6DD-E16B-6242-8B0A-1422AF110278}" v="11" dt="2026-08-27T11:14:05.936"/>
+    <p1510:client id="{029D9992-271B-8144-B9C5-A26B0866EDF2}" v="1" dt="2026-09-01T10:02:54.022"/>
   </p1510:revLst>
 </p1510:revInfo>
 </file>
@@ -217,7 +217,7 @@
           <a:p>
             <a:fld id="{B58D1FFF-3B6F-A440-B2E7-D2C34C2609DB}" type="datetimeFigureOut">
               <a:rPr lang="en-US" smtClean="0"/>
-              <a:t>8/31/26</a:t>
+              <a:t>9/1/26</a:t>
             </a:fld>
             <a:endParaRPr lang="en-US"/>
           </a:p>
@@ -918,7 +918,7 @@
           <a:p>
             <a:fld id="{C4DB08A1-141E-2C40-B982-1317EBA64EC5}" type="datetimeFigureOut">
               <a:rPr lang="en-US" smtClean="0"/>
-              <a:t>8/31/26</a:t>
+              <a:t>9/1/26</a:t>
             </a:fld>
             <a:endParaRPr lang="en-US"/>
           </a:p>
@@ -1069,7 +1069,7 @@
           <a:p>
             <a:fld id="{C4DB08A1-141E-2C40-B982-1317EBA64EC5}" type="datetimeFigureOut">
               <a:rPr lang="en-US" smtClean="0"/>
-              <a:t>8/31/26</a:t>
+              <a:t>9/1/26</a:t>
             </a:fld>
             <a:endParaRPr lang="en-US"/>
           </a:p>
@@ -1335,7 +1335,7 @@
           <a:p>
             <a:fld id="{C4DB08A1-141E-2C40-B982-1317EBA64EC5}" type="datetimeFigureOut">
               <a:rPr lang="en-US" smtClean="0"/>
-              <a:t>8/31/26</a:t>
+              <a:t>9/1/26</a:t>
             </a:fld>
             <a:endParaRPr lang="en-US"/>
           </a:p>
@@ -1631,7 +1631,7 @@
           <a:p>
             <a:fld id="{C4DB08A1-141E-2C40-B982-1317EBA64EC5}" type="datetimeFigureOut">
               <a:rPr lang="en-US" smtClean="0"/>
-              <a:t>8/31/26</a:t>
+              <a:t>9/1/26</a:t>
             </a:fld>
             <a:endParaRPr lang="en-US"/>
           </a:p>
@@ -1782,7 +1782,7 @@
           <a:p>
             <a:fld id="{C4DB08A1-141E-2C40-B982-1317EBA64EC5}" type="datetimeFigureOut">
               <a:rPr lang="en-US" smtClean="0"/>
-              <a:t>8/31/26</a:t>
+              <a:t>9/1/26</a:t>
             </a:fld>
             <a:endParaRPr lang="en-US"/>
           </a:p>
@@ -2048,7 +2048,7 @@
           <a:p>
             <a:fld id="{C4DB08A1-141E-2C40-B982-1317EBA64EC5}" type="datetimeFigureOut">
               <a:rPr lang="en-US" smtClean="0"/>
-              <a:t>8/31/26</a:t>
+              <a:t>9/1/26</a:t>
             </a:fld>
             <a:endParaRPr lang="en-US"/>
           </a:p>
@@ -2344,7 +2344,7 @@
           <a:p>
             <a:fld id="{C4DB08A1-141E-2C40-B982-1317EBA64EC5}" type="datetimeFigureOut">
               <a:rPr lang="en-US" smtClean="0"/>
-              <a:t>8/31/26</a:t>
+              <a:t>9/1/26</a:t>
             </a:fld>
             <a:endParaRPr lang="en-US"/>
           </a:p>
@@ -2897,7 +2897,7 @@
           <a:p>
             <a:fld id="{C4DB08A1-141E-2C40-B982-1317EBA64EC5}" type="datetimeFigureOut">
               <a:rPr lang="en-US" smtClean="0"/>
-              <a:t>8/31/26</a:t>
+              <a:t>9/1/26</a:t>
             </a:fld>
             <a:endParaRPr lang="en-US"/>
           </a:p>
@@ -3121,54 +3121,6 @@
               <a:t>‹#›</a:t>
             </a:fld>
             <a:endParaRPr lang="en-US" dirty="0"/>
-          </a:p>
-        </p:txBody>
-      </p:sp>
-      <p:sp>
-        <p:nvSpPr>
-          <p:cNvPr id="8" name="TextBox 7">
-            <a:extLst>
-              <a:ext uri="{FF2B5EF4-FFF2-40B4-BE49-F238E27FC236}">
-                <a16:creationId xmlns:a16="http://schemas.microsoft.com/office/drawing/2014/main" id="{29B0EAEB-77B1-0A98-76AD-8A4A833F2FDE}"/>
-              </a:ext>
-            </a:extLst>
-          </p:cNvPr>
-          <p:cNvSpPr txBox="1"/>
-          <p:nvPr userDrawn="1">
-            <p:extLst>
-              <p:ext uri="{1162E1C5-73C7-4A58-AE30-91384D911F3F}">
-                <p184:classification xmlns:p184="http://schemas.microsoft.com/office/powerpoint/2018/4/main" val="hdr"/>
-              </p:ext>
-            </p:extLst>
-          </p:nvPr>
-        </p:nvSpPr>
-        <p:spPr>
-          <a:xfrm>
-            <a:off x="5679250" y="63500"/>
-            <a:ext cx="865187" cy="182880"/>
-          </a:xfrm>
-          <a:prstGeom prst="rect">
-            <a:avLst/>
-          </a:prstGeom>
-        </p:spPr>
-        <p:txBody>
-          <a:bodyPr horzOverflow="overflow" lIns="0" tIns="0" rIns="0" bIns="0">
-            <a:spAutoFit/>
-          </a:bodyPr>
-          <a:lstStyle/>
-          <a:p>
-            <a:pPr algn="l"/>
-            <a:r>
-              <a:rPr lang="en-US" sz="1200">
-                <a:solidFill>
-                  <a:srgbClr val="008000">
-                    <a:alpha val="50000"/>
-                  </a:srgbClr>
-                </a:solidFill>
-                <a:latin typeface="Aptos" panose="020B0004020202020204" pitchFamily="34" charset="0"/>
-              </a:rPr>
-              <a:t>RESTRICTED</a:t>
-            </a:r>
           </a:p>
         </p:txBody>
       </p:sp>
@@ -12676,10 +12628,4 @@
     </a:ext>
   </a:extLst>
 </a:theme>
-</file>
-
-<file path=docMetadata/LabelInfo.xml><?xml version="1.0" encoding="utf-8"?>
-<clbl:labelList xmlns:clbl="http://schemas.microsoft.com/office/2020/mipLabelMetadata">
-  <clbl:label id="{ec3fe26b-7d76-4b37-8465-ecc347eca3f0}" enabled="1" method="Standard" siteId="{46c4de19-0ffc-4c54-aa86-ee7274afa9d7}" contentBits="1" removed="0"/>
-</clbl:labelList>
 </file>
</xml_diff>